<commit_message>
Replace the first-slide cow and calf photo with an updated Hereford pair.
Co-authored-by: Cursor <cursoragent@cursor.com>
</commit_message>
<xml_diff>
--- a/Gemelo-Digital-Ganadero-productores.pptx
+++ b/Gemelo-Digital-Ganadero-productores.pptx
@@ -3380,7 +3380,7 @@
       </p:sp>
       <p:pic>
         <p:nvPicPr>
-          <p:cNvPr id="8" name="Picture 7" descr="hereford-vaca-ternero-belgrano.png"/>
+          <p:cNvPr id="8" name="Picture 7" descr="srsl-vaca-ternero-2026.png"/>
           <p:cNvPicPr>
             <a:picLocks noChangeAspect="1"/>
           </p:cNvPicPr>
@@ -3432,7 +3432,7 @@
                 </a:solidFill>
                 <a:latin typeface="Calibri"/>
               </a:rPr>
-              <a:t>Hereford con ternero  ·  cría típica del oeste de San Luis</a:t>
+              <a:t>Hereford con ternero  ·  Sociedad Rural de San Luis</a:t>
             </a:r>
           </a:p>
         </p:txBody>

</xml_diff>